<commit_message>
Trim special-structure boxes to label plus formula
</commit_message>
<xml_diff>
--- a/slides/roofline_page.pptx
+++ b/slides/roofline_page.pptx
@@ -13278,10 +13278,10 @@
                 <a:ea typeface="Microsoft YaHei"/>
                 <a:cs typeface="Microsoft YaHei"/>
               </a:rPr>
-              <a:t>特殊结构计算方法</a:t>
-            </a:r>
-            <a:r>
-              <a:rPr sz="750" b="0">
+              <a:t>特殊结构</a:t>
+            </a:r>
+            <a:r>
+              <a:rPr sz="800" b="0">
                 <a:solidFill>
                   <a:srgbClr val="40708B"/>
                 </a:solidFill>
@@ -13289,7 +13289,7 @@
                 <a:ea typeface="Microsoft YaHei"/>
                 <a:cs typeface="Microsoft YaHei"/>
               </a:rPr>
-              <a:t>　下界公式在这两处要改，否则算出来的「极限」本身就是错的</a:t>
+              <a:t>　下界公式要改两处</a:t>
             </a:r>
           </a:p>
         </p:txBody>
@@ -13302,8 +13302,8 @@
         </p:nvSpPr>
         <p:spPr>
           <a:xfrm>
-            <a:off x="7443216" y="3968496"/>
-            <a:ext cx="4199839" cy="1152144"/>
+            <a:off x="7443216" y="4023360"/>
+            <a:ext cx="4199839" cy="1097280"/>
           </a:xfrm>
           <a:prstGeom prst="roundRect">
             <a:avLst>
@@ -13335,7 +13335,7 @@
         </p:nvSpPr>
         <p:spPr>
           <a:xfrm>
-            <a:off x="7443216" y="3968496"/>
+            <a:off x="7443216" y="4023360"/>
             <a:ext cx="4199839" cy="237744"/>
           </a:xfrm>
           <a:prstGeom prst="roundRect">
@@ -13366,7 +13366,7 @@
         </p:nvSpPr>
         <p:spPr>
           <a:xfrm>
-            <a:off x="7443216" y="4114800"/>
+            <a:off x="7443216" y="4169664"/>
             <a:ext cx="4199839" cy="91440"/>
           </a:xfrm>
           <a:prstGeom prst="rect">
@@ -13395,7 +13395,7 @@
         </p:nvSpPr>
         <p:spPr>
           <a:xfrm>
-            <a:off x="7571232" y="3968496"/>
+            <a:off x="7571232" y="4023360"/>
             <a:ext cx="3943807" cy="237744"/>
           </a:xfrm>
           <a:prstGeom prst="rect">
@@ -13431,17 +13431,6 @@
               </a:rPr>
               <a:t>MoE</a:t>
             </a:r>
-            <a:r>
-              <a:rPr sz="850" b="0">
-                <a:solidFill>
-                  <a:srgbClr val="FFFFFF"/>
-                </a:solidFill>
-                <a:latin typeface="Consolas"/>
-                <a:ea typeface="Microsoft YaHei"/>
-                <a:cs typeface="Microsoft YaHei"/>
-              </a:rPr>
-              <a:t>　Roofline 计算</a:t>
-            </a:r>
           </a:p>
         </p:txBody>
       </p:sp>
@@ -13453,8 +13442,8 @@
         </p:nvSpPr>
         <p:spPr>
           <a:xfrm>
-            <a:off x="7571232" y="4229100"/>
-            <a:ext cx="3943807" cy="160020"/>
+            <a:off x="7571232" y="4297680"/>
+            <a:ext cx="713232" cy="182880"/>
           </a:xfrm>
           <a:prstGeom prst="rect">
             <a:avLst/>
@@ -13479,7 +13468,7 @@
               </a:spcAft>
             </a:pPr>
             <a:r>
-              <a:rPr sz="750" b="1">
+              <a:rPr sz="800" b="1">
                 <a:solidFill>
                   <a:srgbClr val="0F62CE"/>
                 </a:solidFill>
@@ -13487,54 +13476,209 @@
                 <a:ea typeface="Microsoft YaHei"/>
                 <a:cs typeface="Microsoft YaHei"/>
               </a:rPr>
-              <a:t>·　</a:t>
-            </a:r>
-            <a:r>
-              <a:rPr sz="750" b="1">
+              <a:t>激活专家</a:t>
+            </a:r>
+          </a:p>
+        </p:txBody>
+      </p:sp>
+      <p:sp>
+        <p:nvSpPr>
+          <p:cNvPr id="235" name="TextBox 234"/>
+          <p:cNvSpPr txBox="1"/>
+          <p:nvPr/>
+        </p:nvSpPr>
+        <p:spPr>
+          <a:xfrm>
+            <a:off x="8321040" y="4297680"/>
+            <a:ext cx="3193999" cy="182880"/>
+          </a:xfrm>
+          <a:prstGeom prst="rect">
+            <a:avLst/>
+          </a:prstGeom>
+          <a:noFill/>
+        </p:spPr>
+        <p:txBody>
+          <a:bodyPr wrap="square" anchor="ctr" lIns="0" tIns="0" rIns="0" bIns="0">
+            <a:noAutofit/>
+          </a:bodyPr>
+          <a:lstStyle/>
+          <a:p>
+            <a:pPr algn="l" latinLnBrk="0">
+              <a:lnSpc>
+                <a:spcPct val="100000"/>
+              </a:lnSpc>
+              <a:spcBef>
+                <a:spcPts val="0"/>
+              </a:spcBef>
+              <a:spcAft>
+                <a:spcPts val="0"/>
+              </a:spcAft>
+            </a:pPr>
+            <a:r>
+              <a:rPr sz="800" b="0">
                 <a:solidFill>
                   <a:srgbClr val="0A2B45"/>
                 </a:solidFill>
+                <a:latin typeface="Consolas"/>
+                <a:ea typeface="Microsoft YaHei"/>
+                <a:cs typeface="Microsoft YaHei"/>
+              </a:rPr>
+              <a:t>E/EP × [1 − (1 − k/E)^T]</a:t>
+            </a:r>
+          </a:p>
+        </p:txBody>
+      </p:sp>
+      <p:sp>
+        <p:nvSpPr>
+          <p:cNvPr id="236" name="TextBox 235"/>
+          <p:cNvSpPr txBox="1"/>
+          <p:nvPr/>
+        </p:nvSpPr>
+        <p:spPr>
+          <a:xfrm>
+            <a:off x="7571232" y="4498848"/>
+            <a:ext cx="713232" cy="182880"/>
+          </a:xfrm>
+          <a:prstGeom prst="rect">
+            <a:avLst/>
+          </a:prstGeom>
+          <a:noFill/>
+        </p:spPr>
+        <p:txBody>
+          <a:bodyPr wrap="square" anchor="ctr" lIns="0" tIns="0" rIns="0" bIns="0">
+            <a:noAutofit/>
+          </a:bodyPr>
+          <a:lstStyle/>
+          <a:p>
+            <a:pPr algn="l" latinLnBrk="0">
+              <a:lnSpc>
+                <a:spcPct val="100000"/>
+              </a:lnSpc>
+              <a:spcBef>
+                <a:spcPts val="0"/>
+              </a:spcBef>
+              <a:spcAft>
+                <a:spcPts val="0"/>
+              </a:spcAft>
+            </a:pPr>
+            <a:r>
+              <a:rPr sz="800" b="1">
+                <a:solidFill>
+                  <a:srgbClr val="0F62CE"/>
+                </a:solidFill>
                 <a:latin typeface="Microsoft YaHei"/>
                 <a:ea typeface="Microsoft YaHei"/>
                 <a:cs typeface="Microsoft YaHei"/>
               </a:rPr>
-              <a:t>激活专家数按命中率算</a:t>
-            </a:r>
-            <a:r>
-              <a:rPr sz="750" b="0">
+              <a:t>权重字节</a:t>
+            </a:r>
+          </a:p>
+        </p:txBody>
+      </p:sp>
+      <p:sp>
+        <p:nvSpPr>
+          <p:cNvPr id="237" name="TextBox 236"/>
+          <p:cNvSpPr txBox="1"/>
+          <p:nvPr/>
+        </p:nvSpPr>
+        <p:spPr>
+          <a:xfrm>
+            <a:off x="8321040" y="4498848"/>
+            <a:ext cx="3193999" cy="182880"/>
+          </a:xfrm>
+          <a:prstGeom prst="rect">
+            <a:avLst/>
+          </a:prstGeom>
+          <a:noFill/>
+        </p:spPr>
+        <p:txBody>
+          <a:bodyPr wrap="square" anchor="ctr" lIns="0" tIns="0" rIns="0" bIns="0">
+            <a:noAutofit/>
+          </a:bodyPr>
+          <a:lstStyle/>
+          <a:p>
+            <a:pPr algn="l" latinLnBrk="0">
+              <a:lnSpc>
+                <a:spcPct val="100000"/>
+              </a:lnSpc>
+              <a:spcBef>
+                <a:spcPts val="0"/>
+              </a:spcBef>
+              <a:spcAft>
+                <a:spcPts val="0"/>
+              </a:spcAft>
+            </a:pPr>
+            <a:r>
+              <a:rPr sz="800" b="0">
                 <a:solidFill>
                   <a:srgbClr val="0A2B45"/>
                 </a:solidFill>
+                <a:latin typeface="Consolas"/>
+                <a:ea typeface="Microsoft YaHei"/>
+                <a:cs typeface="Microsoft YaHei"/>
+              </a:rPr>
+              <a:t>激活专家 × 3 × hidden × inter × bpp</a:t>
+            </a:r>
+          </a:p>
+        </p:txBody>
+      </p:sp>
+      <p:sp>
+        <p:nvSpPr>
+          <p:cNvPr id="238" name="TextBox 237"/>
+          <p:cNvSpPr txBox="1"/>
+          <p:nvPr/>
+        </p:nvSpPr>
+        <p:spPr>
+          <a:xfrm>
+            <a:off x="7571232" y="4700016"/>
+            <a:ext cx="713232" cy="182880"/>
+          </a:xfrm>
+          <a:prstGeom prst="rect">
+            <a:avLst/>
+          </a:prstGeom>
+          <a:noFill/>
+        </p:spPr>
+        <p:txBody>
+          <a:bodyPr wrap="square" anchor="ctr" lIns="0" tIns="0" rIns="0" bIns="0">
+            <a:noAutofit/>
+          </a:bodyPr>
+          <a:lstStyle/>
+          <a:p>
+            <a:pPr algn="l" latinLnBrk="0">
+              <a:lnSpc>
+                <a:spcPct val="100000"/>
+              </a:lnSpc>
+              <a:spcBef>
+                <a:spcPts val="0"/>
+              </a:spcBef>
+              <a:spcAft>
+                <a:spcPts val="0"/>
+              </a:spcAft>
+            </a:pPr>
+            <a:r>
+              <a:rPr sz="800" b="1">
+                <a:solidFill>
+                  <a:srgbClr val="0F62CE"/>
+                </a:solidFill>
                 <a:latin typeface="Microsoft YaHei"/>
                 <a:ea typeface="Microsoft YaHei"/>
                 <a:cs typeface="Microsoft YaHei"/>
               </a:rPr>
-              <a:t>　</a:t>
-            </a:r>
-            <a:r>
-              <a:rPr sz="750" b="0">
-                <a:solidFill>
-                  <a:srgbClr val="1B4D69"/>
-                </a:solidFill>
-                <a:latin typeface="Microsoft YaHei"/>
-                <a:ea typeface="Microsoft YaHei"/>
-                <a:cs typeface="Microsoft YaHei"/>
-              </a:rPr>
-              <a:t>E/EP × [1 − (1 − k/E)^T]，不是 B×k，也不是全部专家</a:t>
-            </a:r>
-          </a:p>
-        </p:txBody>
-      </p:sp>
-      <p:sp>
-        <p:nvSpPr>
-          <p:cNvPr id="235" name="TextBox 234"/>
-          <p:cNvSpPr txBox="1"/>
-          <p:nvPr/>
-        </p:nvSpPr>
-        <p:spPr>
-          <a:xfrm>
-            <a:off x="7571232" y="4382719"/>
-            <a:ext cx="3943807" cy="160020"/>
+              <a:t>通信字节</a:t>
+            </a:r>
+          </a:p>
+        </p:txBody>
+      </p:sp>
+      <p:sp>
+        <p:nvSpPr>
+          <p:cNvPr id="239" name="TextBox 238"/>
+          <p:cNvSpPr txBox="1"/>
+          <p:nvPr/>
+        </p:nvSpPr>
+        <p:spPr>
+          <a:xfrm>
+            <a:off x="8321040" y="4700016"/>
+            <a:ext cx="3193999" cy="182880"/>
           </a:xfrm>
           <a:prstGeom prst="rect">
             <a:avLst/>
@@ -13559,222 +13703,29 @@
               </a:spcAft>
             </a:pPr>
             <a:r>
-              <a:rPr sz="750" b="1">
-                <a:solidFill>
-                  <a:srgbClr val="0F62CE"/>
-                </a:solidFill>
-                <a:latin typeface="Microsoft YaHei"/>
-                <a:ea typeface="Microsoft YaHei"/>
-                <a:cs typeface="Microsoft YaHei"/>
-              </a:rPr>
-              <a:t>·　</a:t>
-            </a:r>
-            <a:r>
-              <a:rPr sz="750" b="1">
+              <a:rPr sz="800" b="0">
                 <a:solidFill>
                   <a:srgbClr val="0A2B45"/>
                 </a:solidFill>
-                <a:latin typeface="Microsoft YaHei"/>
-                <a:ea typeface="Microsoft YaHei"/>
-                <a:cs typeface="Microsoft YaHei"/>
-              </a:rPr>
-              <a:t>只读激活到的权重</a:t>
-            </a:r>
-            <a:r>
-              <a:rPr sz="750" b="0">
-                <a:solidFill>
-                  <a:srgbClr val="0A2B45"/>
-                </a:solidFill>
-                <a:latin typeface="Microsoft YaHei"/>
-                <a:ea typeface="Microsoft YaHei"/>
-                <a:cs typeface="Microsoft YaHei"/>
-              </a:rPr>
-              <a:t>　</a:t>
-            </a:r>
-            <a:r>
-              <a:rPr sz="750" b="0">
-                <a:solidFill>
-                  <a:srgbClr val="1B4D69"/>
-                </a:solidFill>
-                <a:latin typeface="Microsoft YaHei"/>
-                <a:ea typeface="Microsoft YaHei"/>
-                <a:cs typeface="Microsoft YaHei"/>
-              </a:rPr>
-              <a:t>字节 = 激活专家 × 3 × hidden × inter × bpp</a:t>
-            </a:r>
-          </a:p>
-        </p:txBody>
-      </p:sp>
-      <p:sp>
-        <p:nvSpPr>
-          <p:cNvPr id="236" name="TextBox 235"/>
-          <p:cNvSpPr txBox="1"/>
-          <p:nvPr/>
-        </p:nvSpPr>
-        <p:spPr>
-          <a:xfrm>
-            <a:off x="7571232" y="4536338"/>
-            <a:ext cx="3943807" cy="160020"/>
-          </a:xfrm>
-          <a:prstGeom prst="rect">
-            <a:avLst/>
-          </a:prstGeom>
-          <a:noFill/>
-        </p:spPr>
-        <p:txBody>
-          <a:bodyPr wrap="square" anchor="ctr" lIns="0" tIns="0" rIns="0" bIns="0">
-            <a:noAutofit/>
-          </a:bodyPr>
-          <a:lstStyle/>
-          <a:p>
-            <a:pPr algn="l" latinLnBrk="0">
-              <a:lnSpc>
-                <a:spcPct val="100000"/>
-              </a:lnSpc>
-              <a:spcBef>
-                <a:spcPts val="0"/>
-              </a:spcBef>
-              <a:spcAft>
-                <a:spcPts val="0"/>
-              </a:spcAft>
-            </a:pPr>
-            <a:r>
-              <a:rPr sz="750" b="1">
-                <a:solidFill>
-                  <a:srgbClr val="0F62CE"/>
-                </a:solidFill>
-                <a:latin typeface="Microsoft YaHei"/>
-                <a:ea typeface="Microsoft YaHei"/>
-                <a:cs typeface="Microsoft YaHei"/>
-              </a:rPr>
-              <a:t>·　</a:t>
-            </a:r>
-            <a:r>
-              <a:rPr sz="750" b="1">
-                <a:solidFill>
-                  <a:srgbClr val="0A2B45"/>
-                </a:solidFill>
-                <a:latin typeface="Microsoft YaHei"/>
-                <a:ea typeface="Microsoft YaHei"/>
-                <a:cs typeface="Microsoft YaHei"/>
-              </a:rPr>
-              <a:t>算力按 token–专家对</a:t>
-            </a:r>
-            <a:r>
-              <a:rPr sz="750" b="0">
-                <a:solidFill>
-                  <a:srgbClr val="0A2B45"/>
-                </a:solidFill>
-                <a:latin typeface="Microsoft YaHei"/>
-                <a:ea typeface="Microsoft YaHei"/>
-                <a:cs typeface="Microsoft YaHei"/>
-              </a:rPr>
-              <a:t>　</a:t>
-            </a:r>
-            <a:r>
-              <a:rPr sz="750" b="0">
-                <a:solidFill>
-                  <a:srgbClr val="1B4D69"/>
-                </a:solidFill>
-                <a:latin typeface="Microsoft YaHei"/>
-                <a:ea typeface="Microsoft YaHei"/>
-                <a:cs typeface="Microsoft YaHei"/>
-              </a:rPr>
-              <a:t>FLOP = 2 × T·k/EP × 3 × hidden × inter</a:t>
-            </a:r>
-          </a:p>
-        </p:txBody>
-      </p:sp>
-      <p:sp>
-        <p:nvSpPr>
-          <p:cNvPr id="237" name="TextBox 236"/>
-          <p:cNvSpPr txBox="1"/>
-          <p:nvPr/>
-        </p:nvSpPr>
-        <p:spPr>
-          <a:xfrm>
-            <a:off x="7571232" y="4689957"/>
-            <a:ext cx="3943807" cy="160020"/>
-          </a:xfrm>
-          <a:prstGeom prst="rect">
-            <a:avLst/>
-          </a:prstGeom>
-          <a:noFill/>
-        </p:spPr>
-        <p:txBody>
-          <a:bodyPr wrap="square" anchor="ctr" lIns="0" tIns="0" rIns="0" bIns="0">
-            <a:noAutofit/>
-          </a:bodyPr>
-          <a:lstStyle/>
-          <a:p>
-            <a:pPr algn="l" latinLnBrk="0">
-              <a:lnSpc>
-                <a:spcPct val="100000"/>
-              </a:lnSpc>
-              <a:spcBef>
-                <a:spcPts val="0"/>
-              </a:spcBef>
-              <a:spcAft>
-                <a:spcPts val="0"/>
-              </a:spcAft>
-            </a:pPr>
-            <a:r>
-              <a:rPr sz="750" b="1">
-                <a:solidFill>
-                  <a:srgbClr val="0F62CE"/>
-                </a:solidFill>
-                <a:latin typeface="Microsoft YaHei"/>
-                <a:ea typeface="Microsoft YaHei"/>
-                <a:cs typeface="Microsoft YaHei"/>
-              </a:rPr>
-              <a:t>·　</a:t>
-            </a:r>
-            <a:r>
-              <a:rPr sz="750" b="1">
-                <a:solidFill>
-                  <a:srgbClr val="0A2B45"/>
-                </a:solidFill>
-                <a:latin typeface="Microsoft YaHei"/>
-                <a:ea typeface="Microsoft YaHei"/>
-                <a:cs typeface="Microsoft YaHei"/>
-              </a:rPr>
-              <a:t>dispatch / combine 另记</a:t>
-            </a:r>
-            <a:r>
-              <a:rPr sz="750" b="0">
-                <a:solidFill>
-                  <a:srgbClr val="0A2B45"/>
-                </a:solidFill>
-                <a:latin typeface="Microsoft YaHei"/>
-                <a:ea typeface="Microsoft YaHei"/>
-                <a:cs typeface="Microsoft YaHei"/>
-              </a:rPr>
-              <a:t>　</a:t>
-            </a:r>
-            <a:r>
-              <a:rPr sz="750" b="0">
-                <a:solidFill>
-                  <a:srgbClr val="1B4D69"/>
-                </a:solidFill>
-                <a:latin typeface="Microsoft YaHei"/>
-                <a:ea typeface="Microsoft YaHei"/>
-                <a:cs typeface="Microsoft YaHei"/>
-              </a:rPr>
-              <a:t>T·k·hidden 字节走 all-to-all，fp8 派发减半</a:t>
-            </a:r>
-          </a:p>
-        </p:txBody>
-      </p:sp>
-      <p:sp>
-        <p:nvSpPr>
-          <p:cNvPr id="238" name="Rounded Rectangle 237"/>
+                <a:latin typeface="Consolas"/>
+                <a:ea typeface="Microsoft YaHei"/>
+                <a:cs typeface="Microsoft YaHei"/>
+              </a:rPr>
+              <a:t>T · k · hidden，fp8 派发减半</a:t>
+            </a:r>
+          </a:p>
+        </p:txBody>
+      </p:sp>
+      <p:sp>
+        <p:nvSpPr>
+          <p:cNvPr id="240" name="Rounded Rectangle 239"/>
           <p:cNvSpPr/>
           <p:nvPr/>
         </p:nvSpPr>
         <p:spPr>
           <a:xfrm>
-            <a:off x="7534656" y="4892040"/>
-            <a:ext cx="4016959" cy="192024"/>
+            <a:off x="7534656" y="4873752"/>
+            <a:ext cx="4016959" cy="201168"/>
           </a:xfrm>
           <a:prstGeom prst="roundRect">
             <a:avLst>
@@ -13806,7 +13757,7 @@
               </a:spcAft>
             </a:pPr>
             <a:r>
-              <a:rPr sz="750" b="1">
+              <a:rPr sz="800" b="1">
                 <a:solidFill>
                   <a:srgbClr val="0F62CE"/>
                 </a:solidFill>
@@ -13814,21 +13765,21 @@
                 <a:ea typeface="Microsoft YaHei"/>
                 <a:cs typeface="Microsoft YaHei"/>
               </a:rPr>
-              <a:t>批越小命中的专家越少，读的权重却摊不薄 —— MoE 在 decode 下天然更吃读带宽</a:t>
-            </a:r>
-          </a:p>
-        </p:txBody>
-      </p:sp>
-      <p:sp>
-        <p:nvSpPr>
-          <p:cNvPr id="239" name="Rounded Rectangle 238"/>
+              <a:t>批小 → 命中专家少 → 更吃读带宽</a:t>
+            </a:r>
+          </a:p>
+        </p:txBody>
+      </p:sp>
+      <p:sp>
+        <p:nvSpPr>
+          <p:cNvPr id="241" name="Rounded Rectangle 240"/>
           <p:cNvSpPr/>
           <p:nvPr/>
         </p:nvSpPr>
         <p:spPr>
           <a:xfrm>
-            <a:off x="7443216" y="5212080"/>
-            <a:ext cx="4199839" cy="1152144"/>
+            <a:off x="7443216" y="5248656"/>
+            <a:ext cx="4199839" cy="1097280"/>
           </a:xfrm>
           <a:prstGeom prst="roundRect">
             <a:avLst>
@@ -13854,13 +13805,13 @@
       </p:sp>
       <p:sp>
         <p:nvSpPr>
-          <p:cNvPr id="240" name="Rounded Rectangle 239"/>
+          <p:cNvPr id="242" name="Rounded Rectangle 241"/>
           <p:cNvSpPr/>
           <p:nvPr/>
         </p:nvSpPr>
         <p:spPr>
           <a:xfrm>
-            <a:off x="7443216" y="5212080"/>
+            <a:off x="7443216" y="5248656"/>
             <a:ext cx="4199839" cy="237744"/>
           </a:xfrm>
           <a:prstGeom prst="roundRect">
@@ -13885,13 +13836,13 @@
       </p:sp>
       <p:sp>
         <p:nvSpPr>
-          <p:cNvPr id="241" name="Rectangle 240"/>
+          <p:cNvPr id="243" name="Rectangle 242"/>
           <p:cNvSpPr/>
           <p:nvPr/>
         </p:nvSpPr>
         <p:spPr>
           <a:xfrm>
-            <a:off x="7443216" y="5358384"/>
+            <a:off x="7443216" y="5394960"/>
             <a:ext cx="4199839" cy="91440"/>
           </a:xfrm>
           <a:prstGeom prst="rect">
@@ -13914,13 +13865,13 @@
       </p:sp>
       <p:sp>
         <p:nvSpPr>
-          <p:cNvPr id="242" name="TextBox 241"/>
-          <p:cNvSpPr txBox="1"/>
-          <p:nvPr/>
-        </p:nvSpPr>
-        <p:spPr>
-          <a:xfrm>
-            <a:off x="7571232" y="5212080"/>
+          <p:cNvPr id="244" name="TextBox 243"/>
+          <p:cNvSpPr txBox="1"/>
+          <p:nvPr/>
+        </p:nvSpPr>
+        <p:spPr>
+          <a:xfrm>
+            <a:off x="7571232" y="5248656"/>
             <a:ext cx="3943807" cy="237744"/>
           </a:xfrm>
           <a:prstGeom prst="rect">
@@ -13956,30 +13907,19 @@
               </a:rPr>
               <a:t>投机推理</a:t>
             </a:r>
-            <a:r>
-              <a:rPr sz="850" b="0">
-                <a:solidFill>
-                  <a:srgbClr val="FFFFFF"/>
-                </a:solidFill>
-                <a:latin typeface="Consolas"/>
-                <a:ea typeface="Microsoft YaHei"/>
-                <a:cs typeface="Microsoft YaHei"/>
-              </a:rPr>
-              <a:t>　Roofline 计算</a:t>
-            </a:r>
-          </a:p>
-        </p:txBody>
-      </p:sp>
-      <p:sp>
-        <p:nvSpPr>
-          <p:cNvPr id="243" name="TextBox 242"/>
-          <p:cNvSpPr txBox="1"/>
-          <p:nvPr/>
-        </p:nvSpPr>
-        <p:spPr>
-          <a:xfrm>
-            <a:off x="7571232" y="5472684"/>
-            <a:ext cx="3943807" cy="160020"/>
+          </a:p>
+        </p:txBody>
+      </p:sp>
+      <p:sp>
+        <p:nvSpPr>
+          <p:cNvPr id="245" name="TextBox 244"/>
+          <p:cNvSpPr txBox="1"/>
+          <p:nvPr/>
+        </p:nvSpPr>
+        <p:spPr>
+          <a:xfrm>
+            <a:off x="7571232" y="5522976"/>
+            <a:ext cx="713232" cy="182880"/>
           </a:xfrm>
           <a:prstGeom prst="rect">
             <a:avLst/>
@@ -14004,7 +13944,7 @@
               </a:spcAft>
             </a:pPr>
             <a:r>
-              <a:rPr sz="750" b="1">
+              <a:rPr sz="800" b="1">
                 <a:solidFill>
                   <a:srgbClr val="D2690C"/>
                 </a:solidFill>
@@ -14012,54 +13952,209 @@
                 <a:ea typeface="Microsoft YaHei"/>
                 <a:cs typeface="Microsoft YaHei"/>
               </a:rPr>
-              <a:t>·　</a:t>
-            </a:r>
-            <a:r>
-              <a:rPr sz="750" b="1">
+              <a:t>一步</a:t>
+            </a:r>
+          </a:p>
+        </p:txBody>
+      </p:sp>
+      <p:sp>
+        <p:nvSpPr>
+          <p:cNvPr id="246" name="TextBox 245"/>
+          <p:cNvSpPr txBox="1"/>
+          <p:nvPr/>
+        </p:nvSpPr>
+        <p:spPr>
+          <a:xfrm>
+            <a:off x="8321040" y="5522976"/>
+            <a:ext cx="3193999" cy="182880"/>
+          </a:xfrm>
+          <a:prstGeom prst="rect">
+            <a:avLst/>
+          </a:prstGeom>
+          <a:noFill/>
+        </p:spPr>
+        <p:txBody>
+          <a:bodyPr wrap="square" anchor="ctr" lIns="0" tIns="0" rIns="0" bIns="0">
+            <a:noAutofit/>
+          </a:bodyPr>
+          <a:lstStyle/>
+          <a:p>
+            <a:pPr algn="l" latinLnBrk="0">
+              <a:lnSpc>
+                <a:spcPct val="100000"/>
+              </a:lnSpc>
+              <a:spcBef>
+                <a:spcPts val="0"/>
+              </a:spcBef>
+              <a:spcAft>
+                <a:spcPts val="0"/>
+              </a:spcAft>
+            </a:pPr>
+            <a:r>
+              <a:rPr sz="800" b="0">
                 <a:solidFill>
                   <a:srgbClr val="0A2B45"/>
                 </a:solidFill>
+                <a:latin typeface="Consolas"/>
+                <a:ea typeface="Microsoft YaHei"/>
+                <a:cs typeface="Microsoft YaHei"/>
+              </a:rPr>
+              <a:t>s × draft + verify(s+1) + extend</a:t>
+            </a:r>
+          </a:p>
+        </p:txBody>
+      </p:sp>
+      <p:sp>
+        <p:nvSpPr>
+          <p:cNvPr id="247" name="TextBox 246"/>
+          <p:cNvSpPr txBox="1"/>
+          <p:nvPr/>
+        </p:nvSpPr>
+        <p:spPr>
+          <a:xfrm>
+            <a:off x="7571232" y="5724144"/>
+            <a:ext cx="713232" cy="182880"/>
+          </a:xfrm>
+          <a:prstGeom prst="rect">
+            <a:avLst/>
+          </a:prstGeom>
+          <a:noFill/>
+        </p:spPr>
+        <p:txBody>
+          <a:bodyPr wrap="square" anchor="ctr" lIns="0" tIns="0" rIns="0" bIns="0">
+            <a:noAutofit/>
+          </a:bodyPr>
+          <a:lstStyle/>
+          <a:p>
+            <a:pPr algn="l" latinLnBrk="0">
+              <a:lnSpc>
+                <a:spcPct val="100000"/>
+              </a:lnSpc>
+              <a:spcBef>
+                <a:spcPts val="0"/>
+              </a:spcBef>
+              <a:spcAft>
+                <a:spcPts val="0"/>
+              </a:spcAft>
+            </a:pPr>
+            <a:r>
+              <a:rPr sz="800" b="1">
+                <a:solidFill>
+                  <a:srgbClr val="D2690C"/>
+                </a:solidFill>
                 <a:latin typeface="Microsoft YaHei"/>
                 <a:ea typeface="Microsoft YaHei"/>
                 <a:cs typeface="Microsoft YaHei"/>
               </a:rPr>
-              <a:t>一步不止一次前向</a:t>
-            </a:r>
-            <a:r>
-              <a:rPr sz="750" b="0">
+              <a:t>等效 TPOT</a:t>
+            </a:r>
+          </a:p>
+        </p:txBody>
+      </p:sp>
+      <p:sp>
+        <p:nvSpPr>
+          <p:cNvPr id="248" name="TextBox 247"/>
+          <p:cNvSpPr txBox="1"/>
+          <p:nvPr/>
+        </p:nvSpPr>
+        <p:spPr>
+          <a:xfrm>
+            <a:off x="8321040" y="5724144"/>
+            <a:ext cx="3193999" cy="182880"/>
+          </a:xfrm>
+          <a:prstGeom prst="rect">
+            <a:avLst/>
+          </a:prstGeom>
+          <a:noFill/>
+        </p:spPr>
+        <p:txBody>
+          <a:bodyPr wrap="square" anchor="ctr" lIns="0" tIns="0" rIns="0" bIns="0">
+            <a:noAutofit/>
+          </a:bodyPr>
+          <a:lstStyle/>
+          <a:p>
+            <a:pPr algn="l" latinLnBrk="0">
+              <a:lnSpc>
+                <a:spcPct val="100000"/>
+              </a:lnSpc>
+              <a:spcBef>
+                <a:spcPts val="0"/>
+              </a:spcBef>
+              <a:spcAft>
+                <a:spcPts val="0"/>
+              </a:spcAft>
+            </a:pPr>
+            <a:r>
+              <a:rPr sz="800" b="0">
                 <a:solidFill>
                   <a:srgbClr val="0A2B45"/>
                 </a:solidFill>
+                <a:latin typeface="Consolas"/>
+                <a:ea typeface="Microsoft YaHei"/>
+                <a:cs typeface="Microsoft YaHei"/>
+              </a:rPr>
+              <a:t>一步耗时 ÷ 接受长度</a:t>
+            </a:r>
+          </a:p>
+        </p:txBody>
+      </p:sp>
+      <p:sp>
+        <p:nvSpPr>
+          <p:cNvPr id="249" name="TextBox 248"/>
+          <p:cNvSpPr txBox="1"/>
+          <p:nvPr/>
+        </p:nvSpPr>
+        <p:spPr>
+          <a:xfrm>
+            <a:off x="7571232" y="5925312"/>
+            <a:ext cx="713232" cy="182880"/>
+          </a:xfrm>
+          <a:prstGeom prst="rect">
+            <a:avLst/>
+          </a:prstGeom>
+          <a:noFill/>
+        </p:spPr>
+        <p:txBody>
+          <a:bodyPr wrap="square" anchor="ctr" lIns="0" tIns="0" rIns="0" bIns="0">
+            <a:noAutofit/>
+          </a:bodyPr>
+          <a:lstStyle/>
+          <a:p>
+            <a:pPr algn="l" latinLnBrk="0">
+              <a:lnSpc>
+                <a:spcPct val="100000"/>
+              </a:lnSpc>
+              <a:spcBef>
+                <a:spcPts val="0"/>
+              </a:spcBef>
+              <a:spcAft>
+                <a:spcPts val="0"/>
+              </a:spcAft>
+            </a:pPr>
+            <a:r>
+              <a:rPr sz="800" b="1">
+                <a:solidFill>
+                  <a:srgbClr val="D2690C"/>
+                </a:solidFill>
                 <a:latin typeface="Microsoft YaHei"/>
                 <a:ea typeface="Microsoft YaHei"/>
                 <a:cs typeface="Microsoft YaHei"/>
               </a:rPr>
-              <a:t>　</a:t>
-            </a:r>
-            <a:r>
-              <a:rPr sz="750" b="0">
-                <a:solidFill>
-                  <a:srgbClr val="1B4D69"/>
-                </a:solidFill>
-                <a:latin typeface="Microsoft YaHei"/>
-                <a:ea typeface="Microsoft YaHei"/>
-                <a:cs typeface="Microsoft YaHei"/>
-              </a:rPr>
-              <a:t>s 次 draft + 1 次 verify（s+1 token）+ 1 次 draft extend</a:t>
-            </a:r>
-          </a:p>
-        </p:txBody>
-      </p:sp>
-      <p:sp>
-        <p:nvSpPr>
-          <p:cNvPr id="244" name="TextBox 243"/>
-          <p:cNvSpPr txBox="1"/>
-          <p:nvPr/>
-        </p:nvSpPr>
-        <p:spPr>
-          <a:xfrm>
-            <a:off x="7571232" y="5626303"/>
-            <a:ext cx="3943807" cy="160020"/>
+              <a:t>盈亏线</a:t>
+            </a:r>
+          </a:p>
+        </p:txBody>
+      </p:sp>
+      <p:sp>
+        <p:nvSpPr>
+          <p:cNvPr id="250" name="TextBox 249"/>
+          <p:cNvSpPr txBox="1"/>
+          <p:nvPr/>
+        </p:nvSpPr>
+        <p:spPr>
+          <a:xfrm>
+            <a:off x="8321040" y="5925312"/>
+            <a:ext cx="3193999" cy="182880"/>
           </a:xfrm>
           <a:prstGeom prst="rect">
             <a:avLst/>
@@ -14084,222 +14179,29 @@
               </a:spcAft>
             </a:pPr>
             <a:r>
-              <a:rPr sz="750" b="1">
-                <a:solidFill>
-                  <a:srgbClr val="D2690C"/>
-                </a:solidFill>
-                <a:latin typeface="Microsoft YaHei"/>
-                <a:ea typeface="Microsoft YaHei"/>
-                <a:cs typeface="Microsoft YaHei"/>
-              </a:rPr>
-              <a:t>·　</a:t>
-            </a:r>
-            <a:r>
-              <a:rPr sz="750" b="1">
+              <a:rPr sz="800" b="0">
                 <a:solidFill>
                   <a:srgbClr val="0A2B45"/>
                 </a:solidFill>
-                <a:latin typeface="Microsoft YaHei"/>
-                <a:ea typeface="Microsoft YaHei"/>
-                <a:cs typeface="Microsoft YaHei"/>
-              </a:rPr>
-              <a:t>按等效 TPOT 比</a:t>
-            </a:r>
-            <a:r>
-              <a:rPr sz="750" b="0">
-                <a:solidFill>
-                  <a:srgbClr val="0A2B45"/>
-                </a:solidFill>
-                <a:latin typeface="Microsoft YaHei"/>
-                <a:ea typeface="Microsoft YaHei"/>
-                <a:cs typeface="Microsoft YaHei"/>
-              </a:rPr>
-              <a:t>　</a:t>
-            </a:r>
-            <a:r>
-              <a:rPr sz="750" b="0">
-                <a:solidFill>
-                  <a:srgbClr val="1B4D69"/>
-                </a:solidFill>
-                <a:latin typeface="Microsoft YaHei"/>
-                <a:ea typeface="Microsoft YaHei"/>
-                <a:cs typeface="Microsoft YaHei"/>
-              </a:rPr>
-              <a:t>一步耗时 ÷ 接受长度，才和普通 decode 可比</a:t>
-            </a:r>
-          </a:p>
-        </p:txBody>
-      </p:sp>
-      <p:sp>
-        <p:nvSpPr>
-          <p:cNvPr id="245" name="TextBox 244"/>
-          <p:cNvSpPr txBox="1"/>
-          <p:nvPr/>
-        </p:nvSpPr>
-        <p:spPr>
-          <a:xfrm>
-            <a:off x="7571232" y="5779922"/>
-            <a:ext cx="3943807" cy="160020"/>
-          </a:xfrm>
-          <a:prstGeom prst="rect">
-            <a:avLst/>
-          </a:prstGeom>
-          <a:noFill/>
-        </p:spPr>
-        <p:txBody>
-          <a:bodyPr wrap="square" anchor="ctr" lIns="0" tIns="0" rIns="0" bIns="0">
-            <a:noAutofit/>
-          </a:bodyPr>
-          <a:lstStyle/>
-          <a:p>
-            <a:pPr algn="l" latinLnBrk="0">
-              <a:lnSpc>
-                <a:spcPct val="100000"/>
-              </a:lnSpc>
-              <a:spcBef>
-                <a:spcPts val="0"/>
-              </a:spcBef>
-              <a:spcAft>
-                <a:spcPts val="0"/>
-              </a:spcAft>
-            </a:pPr>
-            <a:r>
-              <a:rPr sz="750" b="1">
-                <a:solidFill>
-                  <a:srgbClr val="D2690C"/>
-                </a:solidFill>
-                <a:latin typeface="Microsoft YaHei"/>
-                <a:ea typeface="Microsoft YaHei"/>
-                <a:cs typeface="Microsoft YaHei"/>
-              </a:rPr>
-              <a:t>·　</a:t>
-            </a:r>
-            <a:r>
-              <a:rPr sz="750" b="1">
-                <a:solidFill>
-                  <a:srgbClr val="0A2B45"/>
-                </a:solidFill>
-                <a:latin typeface="Microsoft YaHei"/>
-                <a:ea typeface="Microsoft YaHei"/>
-                <a:cs typeface="Microsoft YaHei"/>
-              </a:rPr>
-              <a:t>verify 放大了批量</a:t>
-            </a:r>
-            <a:r>
-              <a:rPr sz="750" b="0">
-                <a:solidFill>
-                  <a:srgbClr val="0A2B45"/>
-                </a:solidFill>
-                <a:latin typeface="Microsoft YaHei"/>
-                <a:ea typeface="Microsoft YaHei"/>
-                <a:cs typeface="Microsoft YaHei"/>
-              </a:rPr>
-              <a:t>　</a:t>
-            </a:r>
-            <a:r>
-              <a:rPr sz="750" b="0">
-                <a:solidFill>
-                  <a:srgbClr val="1B4D69"/>
-                </a:solidFill>
-                <a:latin typeface="Microsoft YaHei"/>
-                <a:ea typeface="Microsoft YaHei"/>
-                <a:cs typeface="Microsoft YaHei"/>
-              </a:rPr>
-              <a:t>算术强度随之上升，可能从访存受限翻成算力受限</a:t>
-            </a:r>
-          </a:p>
-        </p:txBody>
-      </p:sp>
-      <p:sp>
-        <p:nvSpPr>
-          <p:cNvPr id="246" name="TextBox 245"/>
-          <p:cNvSpPr txBox="1"/>
-          <p:nvPr/>
-        </p:nvSpPr>
-        <p:spPr>
-          <a:xfrm>
-            <a:off x="7571232" y="5933541"/>
-            <a:ext cx="3943807" cy="160020"/>
-          </a:xfrm>
-          <a:prstGeom prst="rect">
-            <a:avLst/>
-          </a:prstGeom>
-          <a:noFill/>
-        </p:spPr>
-        <p:txBody>
-          <a:bodyPr wrap="square" anchor="ctr" lIns="0" tIns="0" rIns="0" bIns="0">
-            <a:noAutofit/>
-          </a:bodyPr>
-          <a:lstStyle/>
-          <a:p>
-            <a:pPr algn="l" latinLnBrk="0">
-              <a:lnSpc>
-                <a:spcPct val="100000"/>
-              </a:lnSpc>
-              <a:spcBef>
-                <a:spcPts val="0"/>
-              </a:spcBef>
-              <a:spcAft>
-                <a:spcPts val="0"/>
-              </a:spcAft>
-            </a:pPr>
-            <a:r>
-              <a:rPr sz="750" b="1">
-                <a:solidFill>
-                  <a:srgbClr val="D2690C"/>
-                </a:solidFill>
-                <a:latin typeface="Microsoft YaHei"/>
-                <a:ea typeface="Microsoft YaHei"/>
-                <a:cs typeface="Microsoft YaHei"/>
-              </a:rPr>
-              <a:t>·　</a:t>
-            </a:r>
-            <a:r>
-              <a:rPr sz="750" b="1">
-                <a:solidFill>
-                  <a:srgbClr val="0A2B45"/>
-                </a:solidFill>
-                <a:latin typeface="Microsoft YaHei"/>
-                <a:ea typeface="Microsoft YaHei"/>
-                <a:cs typeface="Microsoft YaHei"/>
-              </a:rPr>
-              <a:t>盈亏线写进账本</a:t>
-            </a:r>
-            <a:r>
-              <a:rPr sz="750" b="0">
-                <a:solidFill>
-                  <a:srgbClr val="0A2B45"/>
-                </a:solidFill>
-                <a:latin typeface="Microsoft YaHei"/>
-                <a:ea typeface="Microsoft YaHei"/>
-                <a:cs typeface="Microsoft YaHei"/>
-              </a:rPr>
-              <a:t>　</a:t>
-            </a:r>
-            <a:r>
-              <a:rPr sz="750" b="0">
-                <a:solidFill>
-                  <a:srgbClr val="1B4D69"/>
-                </a:solidFill>
-                <a:latin typeface="Microsoft YaHei"/>
-                <a:ea typeface="Microsoft YaHei"/>
-                <a:cs typeface="Microsoft YaHei"/>
-              </a:rPr>
-              <a:t>接受长度 &lt; 一步耗时 ÷ decode 耗时，就不该开</a:t>
-            </a:r>
-          </a:p>
-        </p:txBody>
-      </p:sp>
-      <p:sp>
-        <p:nvSpPr>
-          <p:cNvPr id="247" name="Rounded Rectangle 246"/>
+                <a:latin typeface="Consolas"/>
+                <a:ea typeface="Microsoft YaHei"/>
+                <a:cs typeface="Microsoft YaHei"/>
+              </a:rPr>
+              <a:t>接受长度 &lt; 一步 ÷ decode 即亏</a:t>
+            </a:r>
+          </a:p>
+        </p:txBody>
+      </p:sp>
+      <p:sp>
+        <p:nvSpPr>
+          <p:cNvPr id="251" name="Rounded Rectangle 250"/>
           <p:cNvSpPr/>
           <p:nvPr/>
         </p:nvSpPr>
         <p:spPr>
           <a:xfrm>
-            <a:off x="7534656" y="6135624"/>
-            <a:ext cx="4016959" cy="192024"/>
+            <a:off x="7534656" y="6099048"/>
+            <a:ext cx="4016959" cy="201168"/>
           </a:xfrm>
           <a:prstGeom prst="roundRect">
             <a:avLst>
@@ -14331,7 +14233,7 @@
               </a:spcAft>
             </a:pPr>
             <a:r>
-              <a:rPr sz="750" b="1">
+              <a:rPr sz="800" b="1">
                 <a:solidFill>
                   <a:srgbClr val="D2690C"/>
                 </a:solidFill>
@@ -14339,14 +14241,14 @@
                 <a:ea typeface="Microsoft YaHei"/>
                 <a:cs typeface="Microsoft YaHei"/>
               </a:rPr>
-              <a:t>芯片拐点越低，verify 越早转算力受限 —— 大批量下投机反而是负收益</a:t>
-            </a:r>
-          </a:p>
-        </p:txBody>
-      </p:sp>
-      <p:sp>
-        <p:nvSpPr>
-          <p:cNvPr id="248" name="TextBox 247"/>
+              <a:t>批大 → verify 转算力受限 → 负收益</a:t>
+            </a:r>
+          </a:p>
+        </p:txBody>
+      </p:sp>
+      <p:sp>
+        <p:nvSpPr>
+          <p:cNvPr id="252" name="TextBox 251"/>
           <p:cNvSpPr txBox="1"/>
           <p:nvPr/>
         </p:nvSpPr>

</xml_diff>